<commit_message>
Please enter the commit message for your changes. Lines starting with '#' will be ignored, and an empty message aborts the commit.
On branch main
Your branch is up to date with 'origin/main'.

Changes to be committed:
	modified:   "document/2\354\260\250 \354\213\234\355\227\230\353\260\234\354\202\254 \354\235\264\355\233\204 \355\224\274\353\223\234\353\260\261.pptx"
	new file:   "document/~$2\354\260\250 \354\213\234\355\227\230\353\260\234\354\202\254 \354\235\264\355\233\204 \355\224\274\353\223\234\353\260\261.pptx"

Changes not staged for commit:
	modified:   .claude/worktrees/unruffled-brahmagupta-7c0d1d (untracked content)
	modified:   SW/Final_v2/src/.claude/worktrees/magical-mestorf-b794e7 (modified content)
</commit_message>
<xml_diff>
--- a/document/2차 시험발사 이후 피드백.pptx
+++ b/document/2차 시험발사 이후 피드백.pptx
@@ -105,6 +105,11 @@
       </a:defRPr>
     </a:lvl9pPr>
   </p:defaultTextStyle>
+  <p:extLst>
+    <p:ext uri="{EFAFB233-063F-42B5-8137-9DF3F51BA10A}">
+      <p15:sldGuideLst xmlns:p15="http://schemas.microsoft.com/office/powerpoint/2012/main"/>
+    </p:ext>
+  </p:extLst>
 </p:presentation>
 </file>
 

</xml_diff>